<commit_message>
Add 3-month action plan slides to Hair Touch by Sandra deck
Two new slides before the closing: a month-by-month plan (Mes 1
discovery/rosemary oil, Mes 2 trust/shampoo, Mes 3 consolidation/full
routine) tying each phase to a protagonist product and to Sandra's
authority, plus a week-by-week execution timeline covering the first
12 weeks. Closing slide renumbered to 18.

Co-Authored-By: Claude Sonnet 5 <noreply@anthropic.com>
Claude-Session: https://claude.ai/code/session_01SmkHKcxHsRiRKSPUZSC2qb
</commit_message>
<xml_diff>
--- a/Andres - Productos para el Cabello (EEUU)/HairTouch_by_Sandra_Metodologia.pptx
+++ b/Andres - Productos para el Cabello (EEUU)/HairTouch_by_Sandra_Metodologia.pptx
@@ -21,9 +21,11 @@
     <p:sldId id="269" r:id="rId15"/>
     <p:sldId id="270" r:id="rId16"/>
     <p:sldId id="271" r:id="rId17"/>
+    <p:sldId id="272" r:id="rId18"/>
+    <p:sldId id="273" r:id="rId19"/>
   </p:sldIdLst>
   <p:notesMasterIdLst>
-    <p:notesMasterId r:id="rId18"/>
+    <p:notesMasterId r:id="rId20"/>
   </p:notesMasterIdLst>
   <p:sldSz cx="12192000" cy="6858000"/>
   <p:notesSz cx="6858000" cy="12192000"/>
@@ -1145,9 +1147,9 @@
           <a:p>
             <a:r>
               <a:rPr lang="en-US" dirty="0"/>
-              <a:t>OBJETIVO: Cerrar con una propuesta de acción clara, sin sonar comercial.
-MENSAJE PRINCIPAL: El crecimiento no depende de publicar más; depende de darle estructura a lo que ya existe.
-QUÉ EXPLICAR: Los tres pasos siguientes son concretos y secuenciales. La siguiente conversación debe definir el alcance y el cronograma de implementación de las cuatro campañas para el mercado de Estados Unidos.</a:t>
+              <a:t>OBJETIVO: Mostrar un plan de trabajo concreto para los primeros 3 meses, conectando cada mes con un producto protagonista y con la autoridad de Sandra.
+MENSAJE PRINCIPAL: La metodología de las 4 etapas no es teórica: se activa de forma progresiva mes a mes, empezando por el aceite de romero, siguiendo con el shampoo y cerrando con la rutina completa.
+QUÉ EXPLICAR: Mes 1 se enfoca en dar a conocer el aceite de romero apoyado en la autoridad de Sandra. Mes 2 construye confianza alrededor del shampoo con prueba social y abre las primeras campañas de conversión. Mes 3 escala lo que mejor funciona y presenta la rutina completa, arrancando ya la etapa de ascensión con las primeras clientas.</a:t>
             </a:r>
             <a:endParaRPr lang="en-US" dirty="0"/>
           </a:p>
@@ -1171,6 +1173,186 @@
             <a:fld id="{F7021451-1387-4CA6-816F-3879F97B5CBC}" type="slidenum">
               <a:rPr lang="en-US"/>
               <a:t>16</a:t>
+            </a:fld>
+            <a:endParaRPr lang="en-US"/>
+          </a:p>
+        </p:txBody>
+      </p:sp>
+    </p:spTree>
+    <p:extLst>
+      <p:ext uri="{BB962C8B-B14F-4D97-AF65-F5344CB8AC3E}">
+        <p14:creationId xmlns:p14="http://schemas.microsoft.com/office/powerpoint/2010/main" val="1024086991"/>
+      </p:ext>
+    </p:extLst>
+  </p:cSld>
+  <p:clrMapOvr>
+    <a:masterClrMapping/>
+  </p:clrMapOvr>
+</p:notes>
+</file>
+
+<file path=ppt/notesSlides/notesSlide17.xml><?xml version="1.0" encoding="utf-8"?>
+<p:notes xmlns:a="http://schemas.openxmlformats.org/drawingml/2006/main" xmlns:r="http://schemas.openxmlformats.org/officeDocument/2006/relationships" xmlns:p="http://schemas.openxmlformats.org/presentationml/2006/main">
+  <p:cSld>
+    <p:spTree>
+      <p:nvGrpSpPr>
+        <p:cNvPr id="1" name=""/>
+        <p:cNvGrpSpPr/>
+        <p:nvPr/>
+      </p:nvGrpSpPr>
+      <p:grpSpPr>
+        <a:xfrm>
+          <a:off x="0" y="0"/>
+          <a:ext cx="0" cy="0"/>
+          <a:chOff x="0" y="0"/>
+          <a:chExt cx="0" cy="0"/>
+        </a:xfrm>
+      </p:grpSpPr>
+      <p:sp>
+        <p:nvSpPr>
+          <p:cNvPr id="2" name="Slide Image Placeholder 1"/>
+          <p:cNvSpPr>
+            <a:spLocks noGrp="1" noRot="1" noChangeAspect="1"/>
+          </p:cNvSpPr>
+          <p:nvPr>
+            <p:ph type="sldImg"/>
+          </p:nvPr>
+        </p:nvSpPr>
+        <p:spPr/>
+      </p:sp>
+      <p:sp>
+        <p:nvSpPr>
+          <p:cNvPr id="3" name="Notes Placeholder 2"/>
+          <p:cNvSpPr>
+            <a:spLocks noGrp="1"/>
+          </p:cNvSpPr>
+          <p:nvPr>
+            <p:ph type="body" idx="1"/>
+          </p:nvPr>
+        </p:nvSpPr>
+        <p:spPr/>
+        <p:txBody>
+          <a:bodyPr/>
+          <a:lstStyle/>
+          <a:p>
+            <a:r>
+              <a:rPr lang="en-US" dirty="0"/>
+              <a:t>OBJETIVO: Dar seguridad mostrando un cronograma detallado y realista para los primeros 3 meses.
+MENSAJE PRINCIPAL: Cada quincena tiene un entregable concreto; no hay ambigüedad sobre qué se está haciendo en cada momento.
+QUÉ EXPLICAR: Las dos primeras semanas son de base técnica (auditoría, píxel), no de campañas activas todavía. A partir de la semana 3 empieza la etapa de Presentación con el aceite de romero, y el sistema se va completando progresivamente hasta arrancar Ascensión al final del mes 3.</a:t>
+            </a:r>
+            <a:endParaRPr lang="en-US" dirty="0"/>
+          </a:p>
+        </p:txBody>
+      </p:sp>
+      <p:sp>
+        <p:nvSpPr>
+          <p:cNvPr id="4" name="Slide Number Placeholder 3"/>
+          <p:cNvSpPr>
+            <a:spLocks noGrp="1"/>
+          </p:cNvSpPr>
+          <p:nvPr>
+            <p:ph type="sldNum" sz="quarter" idx="10"/>
+          </p:nvPr>
+        </p:nvSpPr>
+        <p:spPr/>
+        <p:txBody>
+          <a:bodyPr/>
+          <a:lstStyle/>
+          <a:p>
+            <a:fld id="{F7021451-1387-4CA6-816F-3879F97B5CBC}" type="slidenum">
+              <a:rPr lang="en-US"/>
+              <a:t>17</a:t>
+            </a:fld>
+            <a:endParaRPr lang="en-US"/>
+          </a:p>
+        </p:txBody>
+      </p:sp>
+    </p:spTree>
+    <p:extLst>
+      <p:ext uri="{BB962C8B-B14F-4D97-AF65-F5344CB8AC3E}">
+        <p14:creationId xmlns:p14="http://schemas.microsoft.com/office/powerpoint/2010/main" val="1024086991"/>
+      </p:ext>
+    </p:extLst>
+  </p:cSld>
+  <p:clrMapOvr>
+    <a:masterClrMapping/>
+  </p:clrMapOvr>
+</p:notes>
+</file>
+
+<file path=ppt/notesSlides/notesSlide18.xml><?xml version="1.0" encoding="utf-8"?>
+<p:notes xmlns:a="http://schemas.openxmlformats.org/drawingml/2006/main" xmlns:r="http://schemas.openxmlformats.org/officeDocument/2006/relationships" xmlns:p="http://schemas.openxmlformats.org/presentationml/2006/main">
+  <p:cSld>
+    <p:spTree>
+      <p:nvGrpSpPr>
+        <p:cNvPr id="1" name=""/>
+        <p:cNvGrpSpPr/>
+        <p:nvPr/>
+      </p:nvGrpSpPr>
+      <p:grpSpPr>
+        <a:xfrm>
+          <a:off x="0" y="0"/>
+          <a:ext cx="0" cy="0"/>
+          <a:chOff x="0" y="0"/>
+          <a:chExt cx="0" cy="0"/>
+        </a:xfrm>
+      </p:grpSpPr>
+      <p:sp>
+        <p:nvSpPr>
+          <p:cNvPr id="2" name="Slide Image Placeholder 1"/>
+          <p:cNvSpPr>
+            <a:spLocks noGrp="1" noRot="1" noChangeAspect="1"/>
+          </p:cNvSpPr>
+          <p:nvPr>
+            <p:ph type="sldImg"/>
+          </p:nvPr>
+        </p:nvSpPr>
+        <p:spPr/>
+      </p:sp>
+      <p:sp>
+        <p:nvSpPr>
+          <p:cNvPr id="3" name="Notes Placeholder 2"/>
+          <p:cNvSpPr>
+            <a:spLocks noGrp="1"/>
+          </p:cNvSpPr>
+          <p:nvPr>
+            <p:ph type="body" idx="1"/>
+          </p:nvPr>
+        </p:nvSpPr>
+        <p:spPr/>
+        <p:txBody>
+          <a:bodyPr/>
+          <a:lstStyle/>
+          <a:p>
+            <a:r>
+              <a:rPr lang="en-US" dirty="0"/>
+              <a:t>OBJETIVO: Cerrar con una propuesta de acción clara, sin sonar comercial.
+MENSAJE PRINCIPAL: El crecimiento no depende de publicar más; depende de darle estructura a lo que ya existe.
+QUÉ EXPLICAR: Los tres pasos siguientes son concretos y secuenciales. La siguiente conversación debe definir el alcance y el cronograma de implementación de las cuatro campañas para el mercado de Estados Unidos.</a:t>
+            </a:r>
+            <a:endParaRPr lang="en-US" dirty="0"/>
+          </a:p>
+        </p:txBody>
+      </p:sp>
+      <p:sp>
+        <p:nvSpPr>
+          <p:cNvPr id="4" name="Slide Number Placeholder 3"/>
+          <p:cNvSpPr>
+            <a:spLocks noGrp="1"/>
+          </p:cNvSpPr>
+          <p:nvPr>
+            <p:ph type="sldNum" sz="quarter" idx="10"/>
+          </p:nvPr>
+        </p:nvSpPr>
+        <p:spPr/>
+        <p:txBody>
+          <a:bodyPr/>
+          <a:lstStyle/>
+          <a:p>
+            <a:fld id="{F7021451-1387-4CA6-816F-3879F97B5CBC}" type="slidenum">
+              <a:rPr lang="en-US"/>
+              <a:t>18</a:t>
             </a:fld>
             <a:endParaRPr lang="en-US"/>
           </a:p>
@@ -7333,6 +7515,2186 @@
 <file path=ppt/slides/slide16.xml><?xml version="1.0" encoding="utf-8"?>
 <p:sld xmlns:a="http://schemas.openxmlformats.org/drawingml/2006/main" xmlns:r="http://schemas.openxmlformats.org/officeDocument/2006/relationships" xmlns:p="http://schemas.openxmlformats.org/presentationml/2006/main">
   <p:cSld name="Slide 16">
+    <p:spTree>
+      <p:nvGrpSpPr>
+        <p:cNvPr id="1" name=""/>
+        <p:cNvGrpSpPr/>
+        <p:nvPr/>
+      </p:nvGrpSpPr>
+      <p:grpSpPr>
+        <a:xfrm>
+          <a:off x="0" y="0"/>
+          <a:ext cx="0" cy="0"/>
+          <a:chOff x="0" y="0"/>
+          <a:chExt cx="0" cy="0"/>
+        </a:xfrm>
+      </p:grpSpPr>
+      <p:sp>
+        <p:nvSpPr>
+          <p:cNvPr id="2" name="Text 0"/>
+          <p:cNvSpPr/>
+          <p:nvPr/>
+        </p:nvSpPr>
+        <p:spPr>
+          <a:xfrm>
+            <a:off x="640080" y="502920"/>
+            <a:ext cx="9144000" cy="320040"/>
+          </a:xfrm>
+          <a:prstGeom prst="rect">
+            <a:avLst/>
+          </a:prstGeom>
+          <a:noFill/>
+          <a:ln/>
+        </p:spPr>
+        <p:txBody>
+          <a:bodyPr wrap="square" lIns="0" tIns="0" rIns="0" bIns="0" rtlCol="0" anchor="ctr"/>
+          <a:lstStyle/>
+          <a:p>
+            <a:pPr indent="0" marL="0">
+              <a:buNone/>
+            </a:pPr>
+            <a:r>
+              <a:rPr lang="en-US" sz="1200" b="1" spc="200" kern="0" dirty="0">
+                <a:solidFill>
+                  <a:srgbClr val="1F4A3C"/>
+                </a:solidFill>
+                <a:latin typeface="Calibri" pitchFamily="34" charset="0"/>
+                <a:ea typeface="Calibri" pitchFamily="34" charset="-122"/>
+                <a:cs typeface="Calibri" pitchFamily="34" charset="-120"/>
+              </a:rPr>
+              <a:t>EL PLAN DE TRABAJO</a:t>
+            </a:r>
+            <a:endParaRPr lang="en-US" sz="1200" dirty="0"/>
+          </a:p>
+        </p:txBody>
+      </p:sp>
+      <p:sp>
+        <p:nvSpPr>
+          <p:cNvPr id="3" name="Text 1"/>
+          <p:cNvSpPr/>
+          <p:nvPr/>
+        </p:nvSpPr>
+        <p:spPr>
+          <a:xfrm>
+            <a:off x="640080" y="841248"/>
+            <a:ext cx="10698480" cy="868680"/>
+          </a:xfrm>
+          <a:prstGeom prst="rect">
+            <a:avLst/>
+          </a:prstGeom>
+          <a:noFill/>
+          <a:ln/>
+        </p:spPr>
+        <p:txBody>
+          <a:bodyPr wrap="square" lIns="0" tIns="0" rIns="0" bIns="0" rtlCol="0" anchor="ctr"/>
+          <a:lstStyle/>
+          <a:p>
+            <a:pPr algn="l" indent="0" marL="0">
+              <a:buNone/>
+            </a:pPr>
+            <a:r>
+              <a:rPr lang="en-US" sz="3000" b="1" dirty="0">
+                <a:solidFill>
+                  <a:srgbClr val="141412"/>
+                </a:solidFill>
+                <a:latin typeface="Cambria" pitchFamily="34" charset="0"/>
+                <a:ea typeface="Cambria" pitchFamily="34" charset="-122"/>
+                <a:cs typeface="Cambria" pitchFamily="34" charset="-120"/>
+              </a:rPr>
+              <a:t>Los primeros 3 meses: mes a mes</a:t>
+            </a:r>
+            <a:endParaRPr lang="en-US" sz="3000" dirty="0"/>
+          </a:p>
+        </p:txBody>
+      </p:sp>
+      <p:sp>
+        <p:nvSpPr>
+          <p:cNvPr id="4" name="Text 2"/>
+          <p:cNvSpPr/>
+          <p:nvPr/>
+        </p:nvSpPr>
+        <p:spPr>
+          <a:xfrm>
+            <a:off x="640080" y="1481328"/>
+            <a:ext cx="10607040" cy="457200"/>
+          </a:xfrm>
+          <a:prstGeom prst="rect">
+            <a:avLst/>
+          </a:prstGeom>
+          <a:noFill/>
+          <a:ln/>
+        </p:spPr>
+        <p:txBody>
+          <a:bodyPr wrap="square" lIns="0" tIns="0" rIns="0" bIns="0" rtlCol="0" anchor="ctr"/>
+          <a:lstStyle/>
+          <a:p>
+            <a:pPr indent="0" marL="0">
+              <a:buNone/>
+            </a:pPr>
+            <a:r>
+              <a:rPr lang="en-US" sz="1350" dirty="0">
+                <a:solidFill>
+                  <a:srgbClr val="6B6B66"/>
+                </a:solidFill>
+                <a:latin typeface="Calibri" pitchFamily="34" charset="0"/>
+                <a:ea typeface="Calibri" pitchFamily="34" charset="-122"/>
+                <a:cs typeface="Calibri" pitchFamily="34" charset="-120"/>
+              </a:rPr>
+              <a:t>Cómo posicionamos cada producto con la autoridad de Sandra, mientras aplicamos la metodología de Meta Ads.</a:t>
+            </a:r>
+            <a:endParaRPr lang="en-US" sz="1350" dirty="0"/>
+          </a:p>
+        </p:txBody>
+      </p:sp>
+      <p:sp>
+        <p:nvSpPr>
+          <p:cNvPr id="5" name="Shape 3"/>
+          <p:cNvSpPr/>
+          <p:nvPr/>
+        </p:nvSpPr>
+        <p:spPr>
+          <a:xfrm>
+            <a:off x="640080" y="2148840"/>
+            <a:ext cx="3520440" cy="3977640"/>
+          </a:xfrm>
+          <a:prstGeom prst="roundRect">
+            <a:avLst>
+              <a:gd name="adj" fmla="val 2078"/>
+            </a:avLst>
+          </a:prstGeom>
+          <a:solidFill>
+            <a:srgbClr val="F5F5F3"/>
+          </a:solidFill>
+          <a:ln/>
+        </p:spPr>
+      </p:sp>
+      <p:sp>
+        <p:nvSpPr>
+          <p:cNvPr id="6" name="Shape 4"/>
+          <p:cNvSpPr/>
+          <p:nvPr/>
+        </p:nvSpPr>
+        <p:spPr>
+          <a:xfrm>
+            <a:off x="1005840" y="2423160"/>
+            <a:ext cx="640080" cy="640080"/>
+          </a:xfrm>
+          <a:prstGeom prst="ellipse">
+            <a:avLst/>
+          </a:prstGeom>
+          <a:solidFill>
+            <a:srgbClr val="FFFFFF"/>
+          </a:solidFill>
+          <a:ln/>
+        </p:spPr>
+      </p:sp>
+      <p:pic>
+        <p:nvPicPr>
+          <p:cNvPr id="7" name="Image 0" descr="/tmp/claude-0/-home-user-Presentaciones-y-varios/903c1196-30c4-57a8-b469-52313f1ce01c/scratchpad/andres/icons/leaf_1F4A3C.png">    </p:cNvPr>
+          <p:cNvPicPr>
+            <a:picLocks noChangeAspect="1"/>
+          </p:cNvPicPr>
+          <p:nvPr/>
+        </p:nvPicPr>
+        <p:blipFill>
+          <a:blip r:embed="rId1"/>
+          <a:stretch>
+            <a:fillRect/>
+          </a:stretch>
+        </p:blipFill>
+        <p:spPr>
+          <a:xfrm>
+            <a:off x="1165860" y="2583180"/>
+            <a:ext cx="320040" cy="320040"/>
+          </a:xfrm>
+          <a:prstGeom prst="rect">
+            <a:avLst/>
+          </a:prstGeom>
+        </p:spPr>
+      </p:pic>
+      <p:sp>
+        <p:nvSpPr>
+          <p:cNvPr id="8" name="Text 5"/>
+          <p:cNvSpPr/>
+          <p:nvPr/>
+        </p:nvSpPr>
+        <p:spPr>
+          <a:xfrm>
+            <a:off x="1783080" y="2423160"/>
+            <a:ext cx="2148840" cy="274320"/>
+          </a:xfrm>
+          <a:prstGeom prst="rect">
+            <a:avLst/>
+          </a:prstGeom>
+          <a:noFill/>
+          <a:ln/>
+        </p:spPr>
+        <p:txBody>
+          <a:bodyPr wrap="square" lIns="0" tIns="0" rIns="0" bIns="0" rtlCol="0" anchor="ctr"/>
+          <a:lstStyle/>
+          <a:p>
+            <a:pPr indent="0" marL="0">
+              <a:buNone/>
+            </a:pPr>
+            <a:r>
+              <a:rPr lang="en-US" sz="1100" b="1" spc="100" kern="0" dirty="0">
+                <a:solidFill>
+                  <a:srgbClr val="1F4A3C"/>
+                </a:solidFill>
+                <a:latin typeface="Calibri" pitchFamily="34" charset="0"/>
+                <a:ea typeface="Calibri" pitchFamily="34" charset="-122"/>
+                <a:cs typeface="Calibri" pitchFamily="34" charset="-120"/>
+              </a:rPr>
+              <a:t>MES 1</a:t>
+            </a:r>
+            <a:endParaRPr lang="en-US" sz="1100" dirty="0"/>
+          </a:p>
+        </p:txBody>
+      </p:sp>
+      <p:sp>
+        <p:nvSpPr>
+          <p:cNvPr id="9" name="Text 6"/>
+          <p:cNvSpPr/>
+          <p:nvPr/>
+        </p:nvSpPr>
+        <p:spPr>
+          <a:xfrm>
+            <a:off x="1783080" y="2679192"/>
+            <a:ext cx="2148840" cy="365760"/>
+          </a:xfrm>
+          <a:prstGeom prst="rect">
+            <a:avLst/>
+          </a:prstGeom>
+          <a:noFill/>
+          <a:ln/>
+        </p:spPr>
+        <p:txBody>
+          <a:bodyPr wrap="square" lIns="0" tIns="0" rIns="0" bIns="0" rtlCol="0" anchor="ctr"/>
+          <a:lstStyle/>
+          <a:p>
+            <a:pPr indent="0" marL="0">
+              <a:buNone/>
+            </a:pPr>
+            <a:r>
+              <a:rPr lang="en-US" sz="1700" b="1" dirty="0">
+                <a:solidFill>
+                  <a:srgbClr val="141412"/>
+                </a:solidFill>
+                <a:latin typeface="Cambria" pitchFamily="34" charset="0"/>
+                <a:ea typeface="Cambria" pitchFamily="34" charset="-122"/>
+                <a:cs typeface="Cambria" pitchFamily="34" charset="-120"/>
+              </a:rPr>
+              <a:t>Descubrimiento</a:t>
+            </a:r>
+            <a:endParaRPr lang="en-US" sz="1700" dirty="0"/>
+          </a:p>
+        </p:txBody>
+      </p:sp>
+      <p:sp>
+        <p:nvSpPr>
+          <p:cNvPr id="10" name="Text 7"/>
+          <p:cNvSpPr/>
+          <p:nvPr/>
+        </p:nvSpPr>
+        <p:spPr>
+          <a:xfrm>
+            <a:off x="960120" y="3200400"/>
+            <a:ext cx="2880360" cy="457200"/>
+          </a:xfrm>
+          <a:prstGeom prst="rect">
+            <a:avLst/>
+          </a:prstGeom>
+          <a:noFill/>
+          <a:ln/>
+        </p:spPr>
+        <p:txBody>
+          <a:bodyPr wrap="square" lIns="0" tIns="0" rIns="0" bIns="0" rtlCol="0" anchor="ctr"/>
+          <a:lstStyle/>
+          <a:p>
+            <a:pPr indent="0" marL="0">
+              <a:buNone/>
+            </a:pPr>
+            <a:r>
+              <a:rPr lang="en-US" sz="1050" b="1" dirty="0">
+                <a:solidFill>
+                  <a:srgbClr val="6B6B66"/>
+                </a:solidFill>
+                <a:latin typeface="Calibri" pitchFamily="34" charset="0"/>
+                <a:ea typeface="Calibri" pitchFamily="34" charset="-122"/>
+                <a:cs typeface="Calibri" pitchFamily="34" charset="-120"/>
+              </a:rPr>
+              <a:t>Etapa: </a:t>
+            </a:r>
+            <a:pPr indent="0" marL="0">
+              <a:buNone/>
+            </a:pPr>
+            <a:r>
+              <a:rPr lang="en-US" sz="1050" dirty="0">
+                <a:solidFill>
+                  <a:srgbClr val="6B6B66"/>
+                </a:solidFill>
+                <a:latin typeface="Calibri" pitchFamily="34" charset="0"/>
+                <a:ea typeface="Calibri" pitchFamily="34" charset="-122"/>
+                <a:cs typeface="Calibri" pitchFamily="34" charset="-120"/>
+              </a:rPr>
+              <a:t>Presentación</a:t>
+            </a:r>
+            <a:endParaRPr lang="en-US" sz="1050" dirty="0"/>
+          </a:p>
+        </p:txBody>
+      </p:sp>
+      <p:sp>
+        <p:nvSpPr>
+          <p:cNvPr id="11" name="Text 8"/>
+          <p:cNvSpPr/>
+          <p:nvPr/>
+        </p:nvSpPr>
+        <p:spPr>
+          <a:xfrm>
+            <a:off x="960120" y="3611880"/>
+            <a:ext cx="2880360" cy="320040"/>
+          </a:xfrm>
+          <a:prstGeom prst="rect">
+            <a:avLst/>
+          </a:prstGeom>
+          <a:noFill/>
+          <a:ln/>
+        </p:spPr>
+        <p:txBody>
+          <a:bodyPr wrap="square" lIns="0" tIns="0" rIns="0" bIns="0" rtlCol="0" anchor="ctr"/>
+          <a:lstStyle/>
+          <a:p>
+            <a:pPr indent="0" marL="0">
+              <a:buNone/>
+            </a:pPr>
+            <a:r>
+              <a:rPr lang="en-US" sz="1050" b="1" dirty="0">
+                <a:solidFill>
+                  <a:srgbClr val="6B6B66"/>
+                </a:solidFill>
+                <a:latin typeface="Calibri" pitchFamily="34" charset="0"/>
+                <a:ea typeface="Calibri" pitchFamily="34" charset="-122"/>
+                <a:cs typeface="Calibri" pitchFamily="34" charset="-120"/>
+              </a:rPr>
+              <a:t>Producto protagonista: </a:t>
+            </a:r>
+            <a:pPr indent="0" marL="0">
+              <a:buNone/>
+            </a:pPr>
+            <a:r>
+              <a:rPr lang="en-US" sz="1050" dirty="0">
+                <a:solidFill>
+                  <a:srgbClr val="6B6B66"/>
+                </a:solidFill>
+                <a:latin typeface="Calibri" pitchFamily="34" charset="0"/>
+                <a:ea typeface="Calibri" pitchFamily="34" charset="-122"/>
+                <a:cs typeface="Calibri" pitchFamily="34" charset="-120"/>
+              </a:rPr>
+              <a:t>Aceite de romero</a:t>
+            </a:r>
+            <a:endParaRPr lang="en-US" sz="1050" dirty="0"/>
+          </a:p>
+        </p:txBody>
+      </p:sp>
+      <p:sp>
+        <p:nvSpPr>
+          <p:cNvPr id="12" name="Shape 9"/>
+          <p:cNvSpPr/>
+          <p:nvPr/>
+        </p:nvSpPr>
+        <p:spPr>
+          <a:xfrm>
+            <a:off x="960120" y="4023360"/>
+            <a:ext cx="2880360" cy="0"/>
+          </a:xfrm>
+          <a:prstGeom prst="line">
+            <a:avLst/>
+          </a:prstGeom>
+          <a:noFill/>
+          <a:ln w="12700">
+            <a:solidFill>
+              <a:srgbClr val="E4E3DF"/>
+            </a:solidFill>
+            <a:prstDash val="solid"/>
+          </a:ln>
+        </p:spPr>
+      </p:sp>
+      <p:sp>
+        <p:nvSpPr>
+          <p:cNvPr id="13" name="Text 10"/>
+          <p:cNvSpPr/>
+          <p:nvPr/>
+        </p:nvSpPr>
+        <p:spPr>
+          <a:xfrm>
+            <a:off x="960120" y="4160520"/>
+            <a:ext cx="2880360" cy="621792"/>
+          </a:xfrm>
+          <a:prstGeom prst="rect">
+            <a:avLst/>
+          </a:prstGeom>
+          <a:noFill/>
+          <a:ln/>
+        </p:spPr>
+        <p:txBody>
+          <a:bodyPr wrap="square" lIns="0" tIns="0" rIns="0" bIns="0" rtlCol="0" anchor="ctr"/>
+          <a:lstStyle/>
+          <a:p>
+            <a:pPr marL="342900" indent="-342900">
+              <a:buSzPct val="100000"/>
+              <a:buChar char="–"/>
+            </a:pPr>
+            <a:r>
+              <a:rPr lang="en-US" sz="1030" dirty="0">
+                <a:solidFill>
+                  <a:srgbClr val="141412"/>
+                </a:solidFill>
+                <a:latin typeface="Calibri" pitchFamily="34" charset="0"/>
+                <a:ea typeface="Calibri" pitchFamily="34" charset="-122"/>
+                <a:cs typeface="Calibri" pitchFamily="34" charset="-120"/>
+              </a:rPr>
+              <a:t>Video de Sandra presentando el aceite de romero y su efecto en el cuero cabelludo</a:t>
+            </a:r>
+            <a:endParaRPr lang="en-US" sz="1030" dirty="0"/>
+          </a:p>
+        </p:txBody>
+      </p:sp>
+      <p:sp>
+        <p:nvSpPr>
+          <p:cNvPr id="14" name="Text 11"/>
+          <p:cNvSpPr/>
+          <p:nvPr/>
+        </p:nvSpPr>
+        <p:spPr>
+          <a:xfrm>
+            <a:off x="960120" y="4818888"/>
+            <a:ext cx="2880360" cy="621792"/>
+          </a:xfrm>
+          <a:prstGeom prst="rect">
+            <a:avLst/>
+          </a:prstGeom>
+          <a:noFill/>
+          <a:ln/>
+        </p:spPr>
+        <p:txBody>
+          <a:bodyPr wrap="square" lIns="0" tIns="0" rIns="0" bIns="0" rtlCol="0" anchor="ctr"/>
+          <a:lstStyle/>
+          <a:p>
+            <a:pPr marL="342900" indent="-342900">
+              <a:buSzPct val="100000"/>
+              <a:buChar char="–"/>
+            </a:pPr>
+            <a:r>
+              <a:rPr lang="en-US" sz="1030" dirty="0">
+                <a:solidFill>
+                  <a:srgbClr val="141412"/>
+                </a:solidFill>
+                <a:latin typeface="Calibri" pitchFamily="34" charset="0"/>
+                <a:ea typeface="Calibri" pitchFamily="34" charset="-122"/>
+                <a:cs typeface="Calibri" pitchFamily="34" charset="-120"/>
+              </a:rPr>
+              <a:t>Campañas de reconocimiento dirigidas a Estados Unidos</a:t>
+            </a:r>
+            <a:endParaRPr lang="en-US" sz="1030" dirty="0"/>
+          </a:p>
+        </p:txBody>
+      </p:sp>
+      <p:sp>
+        <p:nvSpPr>
+          <p:cNvPr id="15" name="Text 12"/>
+          <p:cNvSpPr/>
+          <p:nvPr/>
+        </p:nvSpPr>
+        <p:spPr>
+          <a:xfrm>
+            <a:off x="960120" y="5477256"/>
+            <a:ext cx="2880360" cy="621792"/>
+          </a:xfrm>
+          <a:prstGeom prst="rect">
+            <a:avLst/>
+          </a:prstGeom>
+          <a:noFill/>
+          <a:ln/>
+        </p:spPr>
+        <p:txBody>
+          <a:bodyPr wrap="square" lIns="0" tIns="0" rIns="0" bIns="0" rtlCol="0" anchor="ctr"/>
+          <a:lstStyle/>
+          <a:p>
+            <a:pPr marL="342900" indent="-342900">
+              <a:buSzPct val="100000"/>
+              <a:buChar char="–"/>
+            </a:pPr>
+            <a:r>
+              <a:rPr lang="en-US" sz="1030" dirty="0">
+                <a:solidFill>
+                  <a:srgbClr val="141412"/>
+                </a:solidFill>
+                <a:latin typeface="Calibri" pitchFamily="34" charset="0"/>
+                <a:ea typeface="Calibri" pitchFamily="34" charset="-122"/>
+                <a:cs typeface="Calibri" pitchFamily="34" charset="-120"/>
+              </a:rPr>
+              <a:t>Primer público de remarketing desde quienes interactúan</a:t>
+            </a:r>
+            <a:endParaRPr lang="en-US" sz="1030" dirty="0"/>
+          </a:p>
+        </p:txBody>
+      </p:sp>
+      <p:sp>
+        <p:nvSpPr>
+          <p:cNvPr id="16" name="Shape 13"/>
+          <p:cNvSpPr/>
+          <p:nvPr/>
+        </p:nvSpPr>
+        <p:spPr>
+          <a:xfrm>
+            <a:off x="4480560" y="2148840"/>
+            <a:ext cx="3520440" cy="3977640"/>
+          </a:xfrm>
+          <a:prstGeom prst="roundRect">
+            <a:avLst>
+              <a:gd name="adj" fmla="val 2078"/>
+            </a:avLst>
+          </a:prstGeom>
+          <a:solidFill>
+            <a:srgbClr val="141412"/>
+          </a:solidFill>
+          <a:ln/>
+        </p:spPr>
+      </p:sp>
+      <p:sp>
+        <p:nvSpPr>
+          <p:cNvPr id="17" name="Shape 14"/>
+          <p:cNvSpPr/>
+          <p:nvPr/>
+        </p:nvSpPr>
+        <p:spPr>
+          <a:xfrm>
+            <a:off x="4846320" y="2423160"/>
+            <a:ext cx="640080" cy="640080"/>
+          </a:xfrm>
+          <a:prstGeom prst="ellipse">
+            <a:avLst/>
+          </a:prstGeom>
+          <a:solidFill>
+            <a:srgbClr val="201F1B"/>
+          </a:solidFill>
+          <a:ln/>
+        </p:spPr>
+      </p:sp>
+      <p:pic>
+        <p:nvPicPr>
+          <p:cNvPr id="18" name="Image 1" descr="/tmp/claude-0/-home-user-Presentaciones-y-varios/903c1196-30c4-57a8-b469-52313f1ce01c/scratchpad/andres/icons/star_6FA98A.png">    </p:cNvPr>
+          <p:cNvPicPr>
+            <a:picLocks noChangeAspect="1"/>
+          </p:cNvPicPr>
+          <p:nvPr/>
+        </p:nvPicPr>
+        <p:blipFill>
+          <a:blip r:embed="rId2"/>
+          <a:stretch>
+            <a:fillRect/>
+          </a:stretch>
+        </p:blipFill>
+        <p:spPr>
+          <a:xfrm>
+            <a:off x="5006340" y="2583180"/>
+            <a:ext cx="320040" cy="320040"/>
+          </a:xfrm>
+          <a:prstGeom prst="rect">
+            <a:avLst/>
+          </a:prstGeom>
+        </p:spPr>
+      </p:pic>
+      <p:sp>
+        <p:nvSpPr>
+          <p:cNvPr id="19" name="Text 15"/>
+          <p:cNvSpPr/>
+          <p:nvPr/>
+        </p:nvSpPr>
+        <p:spPr>
+          <a:xfrm>
+            <a:off x="5623560" y="2423160"/>
+            <a:ext cx="2148840" cy="274320"/>
+          </a:xfrm>
+          <a:prstGeom prst="rect">
+            <a:avLst/>
+          </a:prstGeom>
+          <a:noFill/>
+          <a:ln/>
+        </p:spPr>
+        <p:txBody>
+          <a:bodyPr wrap="square" lIns="0" tIns="0" rIns="0" bIns="0" rtlCol="0" anchor="ctr"/>
+          <a:lstStyle/>
+          <a:p>
+            <a:pPr indent="0" marL="0">
+              <a:buNone/>
+            </a:pPr>
+            <a:r>
+              <a:rPr lang="en-US" sz="1100" b="1" spc="100" kern="0" dirty="0">
+                <a:solidFill>
+                  <a:srgbClr val="6FA98A"/>
+                </a:solidFill>
+                <a:latin typeface="Calibri" pitchFamily="34" charset="0"/>
+                <a:ea typeface="Calibri" pitchFamily="34" charset="-122"/>
+                <a:cs typeface="Calibri" pitchFamily="34" charset="-120"/>
+              </a:rPr>
+              <a:t>MES 2</a:t>
+            </a:r>
+            <a:endParaRPr lang="en-US" sz="1100" dirty="0"/>
+          </a:p>
+        </p:txBody>
+      </p:sp>
+      <p:sp>
+        <p:nvSpPr>
+          <p:cNvPr id="20" name="Text 16"/>
+          <p:cNvSpPr/>
+          <p:nvPr/>
+        </p:nvSpPr>
+        <p:spPr>
+          <a:xfrm>
+            <a:off x="5623560" y="2679192"/>
+            <a:ext cx="2148840" cy="365760"/>
+          </a:xfrm>
+          <a:prstGeom prst="rect">
+            <a:avLst/>
+          </a:prstGeom>
+          <a:noFill/>
+          <a:ln/>
+        </p:spPr>
+        <p:txBody>
+          <a:bodyPr wrap="square" lIns="0" tIns="0" rIns="0" bIns="0" rtlCol="0" anchor="ctr"/>
+          <a:lstStyle/>
+          <a:p>
+            <a:pPr indent="0" marL="0">
+              <a:buNone/>
+            </a:pPr>
+            <a:r>
+              <a:rPr lang="en-US" sz="1700" b="1" dirty="0">
+                <a:solidFill>
+                  <a:srgbClr val="FFFFFF"/>
+                </a:solidFill>
+                <a:latin typeface="Cambria" pitchFamily="34" charset="0"/>
+                <a:ea typeface="Cambria" pitchFamily="34" charset="-122"/>
+                <a:cs typeface="Cambria" pitchFamily="34" charset="-120"/>
+              </a:rPr>
+              <a:t>Confianza</a:t>
+            </a:r>
+            <a:endParaRPr lang="en-US" sz="1700" dirty="0"/>
+          </a:p>
+        </p:txBody>
+      </p:sp>
+      <p:sp>
+        <p:nvSpPr>
+          <p:cNvPr id="21" name="Text 17"/>
+          <p:cNvSpPr/>
+          <p:nvPr/>
+        </p:nvSpPr>
+        <p:spPr>
+          <a:xfrm>
+            <a:off x="4800600" y="3200400"/>
+            <a:ext cx="2880360" cy="457200"/>
+          </a:xfrm>
+          <a:prstGeom prst="rect">
+            <a:avLst/>
+          </a:prstGeom>
+          <a:noFill/>
+          <a:ln/>
+        </p:spPr>
+        <p:txBody>
+          <a:bodyPr wrap="square" lIns="0" tIns="0" rIns="0" bIns="0" rtlCol="0" anchor="ctr"/>
+          <a:lstStyle/>
+          <a:p>
+            <a:pPr indent="0" marL="0">
+              <a:buNone/>
+            </a:pPr>
+            <a:r>
+              <a:rPr lang="en-US" sz="1050" b="1" dirty="0">
+                <a:solidFill>
+                  <a:srgbClr val="D6D4CE"/>
+                </a:solidFill>
+                <a:latin typeface="Calibri" pitchFamily="34" charset="0"/>
+                <a:ea typeface="Calibri" pitchFamily="34" charset="-122"/>
+                <a:cs typeface="Calibri" pitchFamily="34" charset="-120"/>
+              </a:rPr>
+              <a:t>Etapa: </a:t>
+            </a:r>
+            <a:pPr indent="0" marL="0">
+              <a:buNone/>
+            </a:pPr>
+            <a:r>
+              <a:rPr lang="en-US" sz="1050" dirty="0">
+                <a:solidFill>
+                  <a:srgbClr val="D6D4CE"/>
+                </a:solidFill>
+                <a:latin typeface="Calibri" pitchFamily="34" charset="0"/>
+                <a:ea typeface="Calibri" pitchFamily="34" charset="-122"/>
+                <a:cs typeface="Calibri" pitchFamily="34" charset="-120"/>
+              </a:rPr>
+              <a:t>Evaluación + arranque de Conversión</a:t>
+            </a:r>
+            <a:endParaRPr lang="en-US" sz="1050" dirty="0"/>
+          </a:p>
+        </p:txBody>
+      </p:sp>
+      <p:sp>
+        <p:nvSpPr>
+          <p:cNvPr id="22" name="Text 18"/>
+          <p:cNvSpPr/>
+          <p:nvPr/>
+        </p:nvSpPr>
+        <p:spPr>
+          <a:xfrm>
+            <a:off x="4800600" y="3611880"/>
+            <a:ext cx="2880360" cy="320040"/>
+          </a:xfrm>
+          <a:prstGeom prst="rect">
+            <a:avLst/>
+          </a:prstGeom>
+          <a:noFill/>
+          <a:ln/>
+        </p:spPr>
+        <p:txBody>
+          <a:bodyPr wrap="square" lIns="0" tIns="0" rIns="0" bIns="0" rtlCol="0" anchor="ctr"/>
+          <a:lstStyle/>
+          <a:p>
+            <a:pPr indent="0" marL="0">
+              <a:buNone/>
+            </a:pPr>
+            <a:r>
+              <a:rPr lang="en-US" sz="1050" b="1" dirty="0">
+                <a:solidFill>
+                  <a:srgbClr val="D6D4CE"/>
+                </a:solidFill>
+                <a:latin typeface="Calibri" pitchFamily="34" charset="0"/>
+                <a:ea typeface="Calibri" pitchFamily="34" charset="-122"/>
+                <a:cs typeface="Calibri" pitchFamily="34" charset="-120"/>
+              </a:rPr>
+              <a:t>Producto protagonista: </a:t>
+            </a:r>
+            <a:pPr indent="0" marL="0">
+              <a:buNone/>
+            </a:pPr>
+            <a:r>
+              <a:rPr lang="en-US" sz="1050" dirty="0">
+                <a:solidFill>
+                  <a:srgbClr val="D6D4CE"/>
+                </a:solidFill>
+                <a:latin typeface="Calibri" pitchFamily="34" charset="0"/>
+                <a:ea typeface="Calibri" pitchFamily="34" charset="-122"/>
+                <a:cs typeface="Calibri" pitchFamily="34" charset="-120"/>
+              </a:rPr>
+              <a:t>Shampoo Vive</a:t>
+            </a:r>
+            <a:endParaRPr lang="en-US" sz="1050" dirty="0"/>
+          </a:p>
+        </p:txBody>
+      </p:sp>
+      <p:sp>
+        <p:nvSpPr>
+          <p:cNvPr id="23" name="Shape 19"/>
+          <p:cNvSpPr/>
+          <p:nvPr/>
+        </p:nvSpPr>
+        <p:spPr>
+          <a:xfrm>
+            <a:off x="4800600" y="4023360"/>
+            <a:ext cx="2880360" cy="0"/>
+          </a:xfrm>
+          <a:prstGeom prst="line">
+            <a:avLst/>
+          </a:prstGeom>
+          <a:noFill/>
+          <a:ln w="12700">
+            <a:solidFill>
+              <a:srgbClr val="3A342E"/>
+            </a:solidFill>
+            <a:prstDash val="solid"/>
+          </a:ln>
+        </p:spPr>
+      </p:sp>
+      <p:sp>
+        <p:nvSpPr>
+          <p:cNvPr id="24" name="Text 20"/>
+          <p:cNvSpPr/>
+          <p:nvPr/>
+        </p:nvSpPr>
+        <p:spPr>
+          <a:xfrm>
+            <a:off x="4800600" y="4160520"/>
+            <a:ext cx="2880360" cy="621792"/>
+          </a:xfrm>
+          <a:prstGeom prst="rect">
+            <a:avLst/>
+          </a:prstGeom>
+          <a:noFill/>
+          <a:ln/>
+        </p:spPr>
+        <p:txBody>
+          <a:bodyPr wrap="square" lIns="0" tIns="0" rIns="0" bIns="0" rtlCol="0" anchor="ctr"/>
+          <a:lstStyle/>
+          <a:p>
+            <a:pPr marL="342900" indent="-342900">
+              <a:buSzPct val="100000"/>
+              <a:buChar char="–"/>
+            </a:pPr>
+            <a:r>
+              <a:rPr lang="en-US" sz="1030" dirty="0">
+                <a:solidFill>
+                  <a:srgbClr val="FFFFFF"/>
+                </a:solidFill>
+                <a:latin typeface="Calibri" pitchFamily="34" charset="0"/>
+                <a:ea typeface="Calibri" pitchFamily="34" charset="-122"/>
+                <a:cs typeface="Calibri" pitchFamily="34" charset="-120"/>
+              </a:rPr>
+              <a:t>Reseñas, testimonios y comparativas de uso real</a:t>
+            </a:r>
+            <a:endParaRPr lang="en-US" sz="1030" dirty="0"/>
+          </a:p>
+        </p:txBody>
+      </p:sp>
+      <p:sp>
+        <p:nvSpPr>
+          <p:cNvPr id="25" name="Text 21"/>
+          <p:cNvSpPr/>
+          <p:nvPr/>
+        </p:nvSpPr>
+        <p:spPr>
+          <a:xfrm>
+            <a:off x="4800600" y="4818888"/>
+            <a:ext cx="2880360" cy="621792"/>
+          </a:xfrm>
+          <a:prstGeom prst="rect">
+            <a:avLst/>
+          </a:prstGeom>
+          <a:noFill/>
+          <a:ln/>
+        </p:spPr>
+        <p:txBody>
+          <a:bodyPr wrap="square" lIns="0" tIns="0" rIns="0" bIns="0" rtlCol="0" anchor="ctr"/>
+          <a:lstStyle/>
+          <a:p>
+            <a:pPr marL="342900" indent="-342900">
+              <a:buSzPct val="100000"/>
+              <a:buChar char="–"/>
+            </a:pPr>
+            <a:r>
+              <a:rPr lang="en-US" sz="1030" dirty="0">
+                <a:solidFill>
+                  <a:srgbClr val="FFFFFF"/>
+                </a:solidFill>
+                <a:latin typeface="Calibri" pitchFamily="34" charset="0"/>
+                <a:ea typeface="Calibri" pitchFamily="34" charset="-122"/>
+                <a:cs typeface="Calibri" pitchFamily="34" charset="-120"/>
+              </a:rPr>
+              <a:t>Primeras campañas de conversión con oferta de lanzamiento</a:t>
+            </a:r>
+            <a:endParaRPr lang="en-US" sz="1030" dirty="0"/>
+          </a:p>
+        </p:txBody>
+      </p:sp>
+      <p:sp>
+        <p:nvSpPr>
+          <p:cNvPr id="26" name="Text 22"/>
+          <p:cNvSpPr/>
+          <p:nvPr/>
+        </p:nvSpPr>
+        <p:spPr>
+          <a:xfrm>
+            <a:off x="4800600" y="5477256"/>
+            <a:ext cx="2880360" cy="621792"/>
+          </a:xfrm>
+          <a:prstGeom prst="rect">
+            <a:avLst/>
+          </a:prstGeom>
+          <a:noFill/>
+          <a:ln/>
+        </p:spPr>
+        <p:txBody>
+          <a:bodyPr wrap="square" lIns="0" tIns="0" rIns="0" bIns="0" rtlCol="0" anchor="ctr"/>
+          <a:lstStyle/>
+          <a:p>
+            <a:pPr marL="342900" indent="-342900">
+              <a:buSzPct val="100000"/>
+              <a:buChar char="–"/>
+            </a:pPr>
+            <a:r>
+              <a:rPr lang="en-US" sz="1030" dirty="0">
+                <a:solidFill>
+                  <a:srgbClr val="FFFFFF"/>
+                </a:solidFill>
+                <a:latin typeface="Calibri" pitchFamily="34" charset="0"/>
+                <a:ea typeface="Calibri" pitchFamily="34" charset="-122"/>
+                <a:cs typeface="Calibri" pitchFamily="34" charset="-120"/>
+              </a:rPr>
+              <a:t>Seguimiento de conversiones activo en hairtouchbysandra.com</a:t>
+            </a:r>
+            <a:endParaRPr lang="en-US" sz="1030" dirty="0"/>
+          </a:p>
+        </p:txBody>
+      </p:sp>
+      <p:sp>
+        <p:nvSpPr>
+          <p:cNvPr id="27" name="Shape 23"/>
+          <p:cNvSpPr/>
+          <p:nvPr/>
+        </p:nvSpPr>
+        <p:spPr>
+          <a:xfrm>
+            <a:off x="8321040" y="2148840"/>
+            <a:ext cx="3520440" cy="3977640"/>
+          </a:xfrm>
+          <a:prstGeom prst="roundRect">
+            <a:avLst>
+              <a:gd name="adj" fmla="val 2078"/>
+            </a:avLst>
+          </a:prstGeom>
+          <a:solidFill>
+            <a:srgbClr val="F5F5F3"/>
+          </a:solidFill>
+          <a:ln/>
+        </p:spPr>
+      </p:sp>
+      <p:sp>
+        <p:nvSpPr>
+          <p:cNvPr id="28" name="Shape 24"/>
+          <p:cNvSpPr/>
+          <p:nvPr/>
+        </p:nvSpPr>
+        <p:spPr>
+          <a:xfrm>
+            <a:off x="8686800" y="2423160"/>
+            <a:ext cx="640080" cy="640080"/>
+          </a:xfrm>
+          <a:prstGeom prst="ellipse">
+            <a:avLst/>
+          </a:prstGeom>
+          <a:solidFill>
+            <a:srgbClr val="FFFFFF"/>
+          </a:solidFill>
+          <a:ln/>
+        </p:spPr>
+      </p:sp>
+      <p:pic>
+        <p:nvPicPr>
+          <p:cNvPr id="29" name="Image 2" descr="/tmp/claude-0/-home-user-Presentaciones-y-varios/903c1196-30c4-57a8-b469-52313f1ce01c/scratchpad/andres/icons/rocket_1F4A3C.png">    </p:cNvPr>
+          <p:cNvPicPr>
+            <a:picLocks noChangeAspect="1"/>
+          </p:cNvPicPr>
+          <p:nvPr/>
+        </p:nvPicPr>
+        <p:blipFill>
+          <a:blip r:embed="rId3"/>
+          <a:stretch>
+            <a:fillRect/>
+          </a:stretch>
+        </p:blipFill>
+        <p:spPr>
+          <a:xfrm>
+            <a:off x="8846820" y="2583180"/>
+            <a:ext cx="320040" cy="320040"/>
+          </a:xfrm>
+          <a:prstGeom prst="rect">
+            <a:avLst/>
+          </a:prstGeom>
+        </p:spPr>
+      </p:pic>
+      <p:sp>
+        <p:nvSpPr>
+          <p:cNvPr id="30" name="Text 25"/>
+          <p:cNvSpPr/>
+          <p:nvPr/>
+        </p:nvSpPr>
+        <p:spPr>
+          <a:xfrm>
+            <a:off x="9464040" y="2423160"/>
+            <a:ext cx="2148840" cy="274320"/>
+          </a:xfrm>
+          <a:prstGeom prst="rect">
+            <a:avLst/>
+          </a:prstGeom>
+          <a:noFill/>
+          <a:ln/>
+        </p:spPr>
+        <p:txBody>
+          <a:bodyPr wrap="square" lIns="0" tIns="0" rIns="0" bIns="0" rtlCol="0" anchor="ctr"/>
+          <a:lstStyle/>
+          <a:p>
+            <a:pPr indent="0" marL="0">
+              <a:buNone/>
+            </a:pPr>
+            <a:r>
+              <a:rPr lang="en-US" sz="1100" b="1" spc="100" kern="0" dirty="0">
+                <a:solidFill>
+                  <a:srgbClr val="1F4A3C"/>
+                </a:solidFill>
+                <a:latin typeface="Calibri" pitchFamily="34" charset="0"/>
+                <a:ea typeface="Calibri" pitchFamily="34" charset="-122"/>
+                <a:cs typeface="Calibri" pitchFamily="34" charset="-120"/>
+              </a:rPr>
+              <a:t>MES 3</a:t>
+            </a:r>
+            <a:endParaRPr lang="en-US" sz="1100" dirty="0"/>
+          </a:p>
+        </p:txBody>
+      </p:sp>
+      <p:sp>
+        <p:nvSpPr>
+          <p:cNvPr id="31" name="Text 26"/>
+          <p:cNvSpPr/>
+          <p:nvPr/>
+        </p:nvSpPr>
+        <p:spPr>
+          <a:xfrm>
+            <a:off x="9464040" y="2679192"/>
+            <a:ext cx="2148840" cy="365760"/>
+          </a:xfrm>
+          <a:prstGeom prst="rect">
+            <a:avLst/>
+          </a:prstGeom>
+          <a:noFill/>
+          <a:ln/>
+        </p:spPr>
+        <p:txBody>
+          <a:bodyPr wrap="square" lIns="0" tIns="0" rIns="0" bIns="0" rtlCol="0" anchor="ctr"/>
+          <a:lstStyle/>
+          <a:p>
+            <a:pPr indent="0" marL="0">
+              <a:buNone/>
+            </a:pPr>
+            <a:r>
+              <a:rPr lang="en-US" sz="1700" b="1" dirty="0">
+                <a:solidFill>
+                  <a:srgbClr val="141412"/>
+                </a:solidFill>
+                <a:latin typeface="Cambria" pitchFamily="34" charset="0"/>
+                <a:ea typeface="Cambria" pitchFamily="34" charset="-122"/>
+                <a:cs typeface="Cambria" pitchFamily="34" charset="-120"/>
+              </a:rPr>
+              <a:t>Consolidación</a:t>
+            </a:r>
+            <a:endParaRPr lang="en-US" sz="1700" dirty="0"/>
+          </a:p>
+        </p:txBody>
+      </p:sp>
+      <p:sp>
+        <p:nvSpPr>
+          <p:cNvPr id="32" name="Text 27"/>
+          <p:cNvSpPr/>
+          <p:nvPr/>
+        </p:nvSpPr>
+        <p:spPr>
+          <a:xfrm>
+            <a:off x="8641080" y="3200400"/>
+            <a:ext cx="2880360" cy="457200"/>
+          </a:xfrm>
+          <a:prstGeom prst="rect">
+            <a:avLst/>
+          </a:prstGeom>
+          <a:noFill/>
+          <a:ln/>
+        </p:spPr>
+        <p:txBody>
+          <a:bodyPr wrap="square" lIns="0" tIns="0" rIns="0" bIns="0" rtlCol="0" anchor="ctr"/>
+          <a:lstStyle/>
+          <a:p>
+            <a:pPr indent="0" marL="0">
+              <a:buNone/>
+            </a:pPr>
+            <a:r>
+              <a:rPr lang="en-US" sz="1050" b="1" dirty="0">
+                <a:solidFill>
+                  <a:srgbClr val="6B6B66"/>
+                </a:solidFill>
+                <a:latin typeface="Calibri" pitchFamily="34" charset="0"/>
+                <a:ea typeface="Calibri" pitchFamily="34" charset="-122"/>
+                <a:cs typeface="Calibri" pitchFamily="34" charset="-120"/>
+              </a:rPr>
+              <a:t>Etapa: </a:t>
+            </a:r>
+            <a:pPr indent="0" marL="0">
+              <a:buNone/>
+            </a:pPr>
+            <a:r>
+              <a:rPr lang="en-US" sz="1050" dirty="0">
+                <a:solidFill>
+                  <a:srgbClr val="6B6B66"/>
+                </a:solidFill>
+                <a:latin typeface="Calibri" pitchFamily="34" charset="0"/>
+                <a:ea typeface="Calibri" pitchFamily="34" charset="-122"/>
+                <a:cs typeface="Calibri" pitchFamily="34" charset="-120"/>
+              </a:rPr>
+              <a:t>Conversión escalada + arranque de Ascensión</a:t>
+            </a:r>
+            <a:endParaRPr lang="en-US" sz="1050" dirty="0"/>
+          </a:p>
+        </p:txBody>
+      </p:sp>
+      <p:sp>
+        <p:nvSpPr>
+          <p:cNvPr id="33" name="Text 28"/>
+          <p:cNvSpPr/>
+          <p:nvPr/>
+        </p:nvSpPr>
+        <p:spPr>
+          <a:xfrm>
+            <a:off x="8641080" y="3611880"/>
+            <a:ext cx="2880360" cy="320040"/>
+          </a:xfrm>
+          <a:prstGeom prst="rect">
+            <a:avLst/>
+          </a:prstGeom>
+          <a:noFill/>
+          <a:ln/>
+        </p:spPr>
+        <p:txBody>
+          <a:bodyPr wrap="square" lIns="0" tIns="0" rIns="0" bIns="0" rtlCol="0" anchor="ctr"/>
+          <a:lstStyle/>
+          <a:p>
+            <a:pPr indent="0" marL="0">
+              <a:buNone/>
+            </a:pPr>
+            <a:r>
+              <a:rPr lang="en-US" sz="1050" b="1" dirty="0">
+                <a:solidFill>
+                  <a:srgbClr val="6B6B66"/>
+                </a:solidFill>
+                <a:latin typeface="Calibri" pitchFamily="34" charset="0"/>
+                <a:ea typeface="Calibri" pitchFamily="34" charset="-122"/>
+                <a:cs typeface="Calibri" pitchFamily="34" charset="-120"/>
+              </a:rPr>
+              <a:t>Producto protagonista: </a:t>
+            </a:r>
+            <a:pPr indent="0" marL="0">
+              <a:buNone/>
+            </a:pPr>
+            <a:r>
+              <a:rPr lang="en-US" sz="1050" dirty="0">
+                <a:solidFill>
+                  <a:srgbClr val="6B6B66"/>
+                </a:solidFill>
+                <a:latin typeface="Calibri" pitchFamily="34" charset="0"/>
+                <a:ea typeface="Calibri" pitchFamily="34" charset="-122"/>
+                <a:cs typeface="Calibri" pitchFamily="34" charset="-120"/>
+              </a:rPr>
+              <a:t>Rutina completa</a:t>
+            </a:r>
+            <a:endParaRPr lang="en-US" sz="1050" dirty="0"/>
+          </a:p>
+        </p:txBody>
+      </p:sp>
+      <p:sp>
+        <p:nvSpPr>
+          <p:cNvPr id="34" name="Shape 29"/>
+          <p:cNvSpPr/>
+          <p:nvPr/>
+        </p:nvSpPr>
+        <p:spPr>
+          <a:xfrm>
+            <a:off x="8641080" y="4023360"/>
+            <a:ext cx="2880360" cy="0"/>
+          </a:xfrm>
+          <a:prstGeom prst="line">
+            <a:avLst/>
+          </a:prstGeom>
+          <a:noFill/>
+          <a:ln w="12700">
+            <a:solidFill>
+              <a:srgbClr val="E4E3DF"/>
+            </a:solidFill>
+            <a:prstDash val="solid"/>
+          </a:ln>
+        </p:spPr>
+      </p:sp>
+      <p:sp>
+        <p:nvSpPr>
+          <p:cNvPr id="35" name="Text 30"/>
+          <p:cNvSpPr/>
+          <p:nvPr/>
+        </p:nvSpPr>
+        <p:spPr>
+          <a:xfrm>
+            <a:off x="8641080" y="4160520"/>
+            <a:ext cx="2880360" cy="621792"/>
+          </a:xfrm>
+          <a:prstGeom prst="rect">
+            <a:avLst/>
+          </a:prstGeom>
+          <a:noFill/>
+          <a:ln/>
+        </p:spPr>
+        <p:txBody>
+          <a:bodyPr wrap="square" lIns="0" tIns="0" rIns="0" bIns="0" rtlCol="0" anchor="ctr"/>
+          <a:lstStyle/>
+          <a:p>
+            <a:pPr marL="342900" indent="-342900">
+              <a:buSzPct val="100000"/>
+              <a:buChar char="–"/>
+            </a:pPr>
+            <a:r>
+              <a:rPr lang="en-US" sz="1030" dirty="0">
+                <a:solidFill>
+                  <a:srgbClr val="141412"/>
+                </a:solidFill>
+                <a:latin typeface="Calibri" pitchFamily="34" charset="0"/>
+                <a:ea typeface="Calibri" pitchFamily="34" charset="-122"/>
+                <a:cs typeface="Calibri" pitchFamily="34" charset="-120"/>
+              </a:rPr>
+              <a:t>Se escalan las campañas de conversión con mejor desempeño</a:t>
+            </a:r>
+            <a:endParaRPr lang="en-US" sz="1030" dirty="0"/>
+          </a:p>
+        </p:txBody>
+      </p:sp>
+      <p:sp>
+        <p:nvSpPr>
+          <p:cNvPr id="36" name="Text 31"/>
+          <p:cNvSpPr/>
+          <p:nvPr/>
+        </p:nvSpPr>
+        <p:spPr>
+          <a:xfrm>
+            <a:off x="8641080" y="4818888"/>
+            <a:ext cx="2880360" cy="621792"/>
+          </a:xfrm>
+          <a:prstGeom prst="rect">
+            <a:avLst/>
+          </a:prstGeom>
+          <a:noFill/>
+          <a:ln/>
+        </p:spPr>
+        <p:txBody>
+          <a:bodyPr wrap="square" lIns="0" tIns="0" rIns="0" bIns="0" rtlCol="0" anchor="ctr"/>
+          <a:lstStyle/>
+          <a:p>
+            <a:pPr marL="342900" indent="-342900">
+              <a:buSzPct val="100000"/>
+              <a:buChar char="–"/>
+            </a:pPr>
+            <a:r>
+              <a:rPr lang="en-US" sz="1030" dirty="0">
+                <a:solidFill>
+                  <a:srgbClr val="141412"/>
+                </a:solidFill>
+                <a:latin typeface="Calibri" pitchFamily="34" charset="0"/>
+                <a:ea typeface="Calibri" pitchFamily="34" charset="-122"/>
+                <a:cs typeface="Calibri" pitchFamily="34" charset="-120"/>
+              </a:rPr>
+              <a:t>La rutina completa (aceite, shampoo, leave-in) como oferta principal</a:t>
+            </a:r>
+            <a:endParaRPr lang="en-US" sz="1030" dirty="0"/>
+          </a:p>
+        </p:txBody>
+      </p:sp>
+      <p:sp>
+        <p:nvSpPr>
+          <p:cNvPr id="37" name="Text 32"/>
+          <p:cNvSpPr/>
+          <p:nvPr/>
+        </p:nvSpPr>
+        <p:spPr>
+          <a:xfrm>
+            <a:off x="8641080" y="5477256"/>
+            <a:ext cx="2880360" cy="621792"/>
+          </a:xfrm>
+          <a:prstGeom prst="rect">
+            <a:avLst/>
+          </a:prstGeom>
+          <a:noFill/>
+          <a:ln/>
+        </p:spPr>
+        <p:txBody>
+          <a:bodyPr wrap="square" lIns="0" tIns="0" rIns="0" bIns="0" rtlCol="0" anchor="ctr"/>
+          <a:lstStyle/>
+          <a:p>
+            <a:pPr marL="342900" indent="-342900">
+              <a:buSzPct val="100000"/>
+              <a:buChar char="–"/>
+            </a:pPr>
+            <a:r>
+              <a:rPr lang="en-US" sz="1030" dirty="0">
+                <a:solidFill>
+                  <a:srgbClr val="141412"/>
+                </a:solidFill>
+                <a:latin typeface="Calibri" pitchFamily="34" charset="0"/>
+                <a:ea typeface="Calibri" pitchFamily="34" charset="-122"/>
+                <a:cs typeface="Calibri" pitchFamily="34" charset="-120"/>
+              </a:rPr>
+              <a:t>Primer público de recompra para clientas ya adquiridas</a:t>
+            </a:r>
+            <a:endParaRPr lang="en-US" sz="1030" dirty="0"/>
+          </a:p>
+        </p:txBody>
+      </p:sp>
+      <p:sp>
+        <p:nvSpPr>
+          <p:cNvPr id="38" name="Text 33"/>
+          <p:cNvSpPr/>
+          <p:nvPr/>
+        </p:nvSpPr>
+        <p:spPr>
+          <a:xfrm>
+            <a:off x="11365992" y="6400800"/>
+            <a:ext cx="548640" cy="274320"/>
+          </a:xfrm>
+          <a:prstGeom prst="rect">
+            <a:avLst/>
+          </a:prstGeom>
+          <a:noFill/>
+          <a:ln/>
+        </p:spPr>
+        <p:txBody>
+          <a:bodyPr wrap="square" lIns="0" tIns="0" rIns="0" bIns="0" rtlCol="0" anchor="ctr"/>
+          <a:lstStyle/>
+          <a:p>
+            <a:pPr algn="r" indent="0" marL="0">
+              <a:buNone/>
+            </a:pPr>
+            <a:r>
+              <a:rPr lang="en-US" sz="1000" dirty="0">
+                <a:solidFill>
+                  <a:srgbClr val="6B6B66"/>
+                </a:solidFill>
+                <a:latin typeface="Calibri" pitchFamily="34" charset="0"/>
+                <a:ea typeface="Calibri" pitchFamily="34" charset="-122"/>
+                <a:cs typeface="Calibri" pitchFamily="34" charset="-120"/>
+              </a:rPr>
+              <a:t>16</a:t>
+            </a:r>
+            <a:endParaRPr lang="en-US" sz="1000" dirty="0"/>
+          </a:p>
+        </p:txBody>
+      </p:sp>
+    </p:spTree>
+  </p:cSld>
+  <p:clrMapOvr>
+    <a:masterClrMapping/>
+  </p:clrMapOvr>
+</p:sld>
+</file>
+
+<file path=ppt/slides/slide17.xml><?xml version="1.0" encoding="utf-8"?>
+<p:sld xmlns:a="http://schemas.openxmlformats.org/drawingml/2006/main" xmlns:r="http://schemas.openxmlformats.org/officeDocument/2006/relationships" xmlns:p="http://schemas.openxmlformats.org/presentationml/2006/main">
+  <p:cSld name="Slide 17">
+    <p:spTree>
+      <p:nvGrpSpPr>
+        <p:cNvPr id="1" name=""/>
+        <p:cNvGrpSpPr/>
+        <p:nvPr/>
+      </p:nvGrpSpPr>
+      <p:grpSpPr>
+        <a:xfrm>
+          <a:off x="0" y="0"/>
+          <a:ext cx="0" cy="0"/>
+          <a:chOff x="0" y="0"/>
+          <a:chExt cx="0" cy="0"/>
+        </a:xfrm>
+      </p:grpSpPr>
+      <p:sp>
+        <p:nvSpPr>
+          <p:cNvPr id="2" name="Text 0"/>
+          <p:cNvSpPr/>
+          <p:nvPr/>
+        </p:nvSpPr>
+        <p:spPr>
+          <a:xfrm>
+            <a:off x="640080" y="502920"/>
+            <a:ext cx="9144000" cy="320040"/>
+          </a:xfrm>
+          <a:prstGeom prst="rect">
+            <a:avLst/>
+          </a:prstGeom>
+          <a:noFill/>
+          <a:ln/>
+        </p:spPr>
+        <p:txBody>
+          <a:bodyPr wrap="square" lIns="0" tIns="0" rIns="0" bIns="0" rtlCol="0" anchor="ctr"/>
+          <a:lstStyle/>
+          <a:p>
+            <a:pPr indent="0" marL="0">
+              <a:buNone/>
+            </a:pPr>
+            <a:r>
+              <a:rPr lang="en-US" sz="1200" b="1" spc="200" kern="0" dirty="0">
+                <a:solidFill>
+                  <a:srgbClr val="1F4A3C"/>
+                </a:solidFill>
+                <a:latin typeface="Calibri" pitchFamily="34" charset="0"/>
+                <a:ea typeface="Calibri" pitchFamily="34" charset="-122"/>
+                <a:cs typeface="Calibri" pitchFamily="34" charset="-120"/>
+              </a:rPr>
+              <a:t>EL PLAN DE TRABAJO</a:t>
+            </a:r>
+            <a:endParaRPr lang="en-US" sz="1200" dirty="0"/>
+          </a:p>
+        </p:txBody>
+      </p:sp>
+      <p:sp>
+        <p:nvSpPr>
+          <p:cNvPr id="3" name="Text 1"/>
+          <p:cNvSpPr/>
+          <p:nvPr/>
+        </p:nvSpPr>
+        <p:spPr>
+          <a:xfrm>
+            <a:off x="640080" y="841248"/>
+            <a:ext cx="10698480" cy="868680"/>
+          </a:xfrm>
+          <a:prstGeom prst="rect">
+            <a:avLst/>
+          </a:prstGeom>
+          <a:noFill/>
+          <a:ln/>
+        </p:spPr>
+        <p:txBody>
+          <a:bodyPr wrap="square" lIns="0" tIns="0" rIns="0" bIns="0" rtlCol="0" anchor="ctr"/>
+          <a:lstStyle/>
+          <a:p>
+            <a:pPr algn="l" indent="0" marL="0">
+              <a:buNone/>
+            </a:pPr>
+            <a:r>
+              <a:rPr lang="en-US" sz="3200" b="1" dirty="0">
+                <a:solidFill>
+                  <a:srgbClr val="141412"/>
+                </a:solidFill>
+                <a:latin typeface="Cambria" pitchFamily="34" charset="0"/>
+                <a:ea typeface="Cambria" pitchFamily="34" charset="-122"/>
+                <a:cs typeface="Cambria" pitchFamily="34" charset="-120"/>
+              </a:rPr>
+              <a:t>Cronograma semana a semana</a:t>
+            </a:r>
+            <a:endParaRPr lang="en-US" sz="3200" dirty="0"/>
+          </a:p>
+        </p:txBody>
+      </p:sp>
+      <p:sp>
+        <p:nvSpPr>
+          <p:cNvPr id="4" name="Text 2"/>
+          <p:cNvSpPr/>
+          <p:nvPr/>
+        </p:nvSpPr>
+        <p:spPr>
+          <a:xfrm>
+            <a:off x="640080" y="1481328"/>
+            <a:ext cx="9144000" cy="365760"/>
+          </a:xfrm>
+          <a:prstGeom prst="rect">
+            <a:avLst/>
+          </a:prstGeom>
+          <a:noFill/>
+          <a:ln/>
+        </p:spPr>
+        <p:txBody>
+          <a:bodyPr wrap="square" lIns="0" tIns="0" rIns="0" bIns="0" rtlCol="0" anchor="ctr"/>
+          <a:lstStyle/>
+          <a:p>
+            <a:pPr indent="0" marL="0">
+              <a:buNone/>
+            </a:pPr>
+            <a:r>
+              <a:rPr lang="en-US" sz="1500" dirty="0">
+                <a:solidFill>
+                  <a:srgbClr val="6B6B66"/>
+                </a:solidFill>
+                <a:latin typeface="Calibri" pitchFamily="34" charset="0"/>
+                <a:ea typeface="Calibri" pitchFamily="34" charset="-122"/>
+                <a:cs typeface="Calibri" pitchFamily="34" charset="-120"/>
+              </a:rPr>
+              <a:t>La ejecución detrás de cada mes.</a:t>
+            </a:r>
+            <a:endParaRPr lang="en-US" sz="1500" dirty="0"/>
+          </a:p>
+        </p:txBody>
+      </p:sp>
+      <p:sp>
+        <p:nvSpPr>
+          <p:cNvPr id="5" name="Shape 3"/>
+          <p:cNvSpPr/>
+          <p:nvPr/>
+        </p:nvSpPr>
+        <p:spPr>
+          <a:xfrm>
+            <a:off x="402336" y="2377440"/>
+            <a:ext cx="1783080" cy="2286000"/>
+          </a:xfrm>
+          <a:prstGeom prst="roundRect">
+            <a:avLst>
+              <a:gd name="adj" fmla="val 4103"/>
+            </a:avLst>
+          </a:prstGeom>
+          <a:solidFill>
+            <a:srgbClr val="F5F5F3"/>
+          </a:solidFill>
+          <a:ln/>
+        </p:spPr>
+      </p:sp>
+      <p:sp>
+        <p:nvSpPr>
+          <p:cNvPr id="6" name="Text 4"/>
+          <p:cNvSpPr/>
+          <p:nvPr/>
+        </p:nvSpPr>
+        <p:spPr>
+          <a:xfrm>
+            <a:off x="539496" y="2606040"/>
+            <a:ext cx="1508760" cy="365760"/>
+          </a:xfrm>
+          <a:prstGeom prst="rect">
+            <a:avLst/>
+          </a:prstGeom>
+          <a:noFill/>
+          <a:ln/>
+        </p:spPr>
+        <p:txBody>
+          <a:bodyPr wrap="square" lIns="0" tIns="0" rIns="0" bIns="0" rtlCol="0" anchor="ctr"/>
+          <a:lstStyle/>
+          <a:p>
+            <a:pPr algn="ctr" indent="0" marL="0">
+              <a:buNone/>
+            </a:pPr>
+            <a:r>
+              <a:rPr lang="en-US" sz="1300" b="1" dirty="0">
+                <a:solidFill>
+                  <a:srgbClr val="1F4A3C"/>
+                </a:solidFill>
+                <a:latin typeface="Cambria" pitchFamily="34" charset="0"/>
+                <a:ea typeface="Cambria" pitchFamily="34" charset="-122"/>
+                <a:cs typeface="Cambria" pitchFamily="34" charset="-120"/>
+              </a:rPr>
+              <a:t>Semana 1-2</a:t>
+            </a:r>
+            <a:endParaRPr lang="en-US" sz="1300" dirty="0"/>
+          </a:p>
+        </p:txBody>
+      </p:sp>
+      <p:sp>
+        <p:nvSpPr>
+          <p:cNvPr id="7" name="Text 5"/>
+          <p:cNvSpPr/>
+          <p:nvPr/>
+        </p:nvSpPr>
+        <p:spPr>
+          <a:xfrm>
+            <a:off x="566928" y="3063240"/>
+            <a:ext cx="1453896" cy="1463040"/>
+          </a:xfrm>
+          <a:prstGeom prst="rect">
+            <a:avLst/>
+          </a:prstGeom>
+          <a:noFill/>
+          <a:ln/>
+        </p:spPr>
+        <p:txBody>
+          <a:bodyPr wrap="square" lIns="0" tIns="0" rIns="0" bIns="0" rtlCol="0" anchor="ctr"/>
+          <a:lstStyle/>
+          <a:p>
+            <a:pPr algn="ctr" indent="0" marL="0">
+              <a:buNone/>
+            </a:pPr>
+            <a:r>
+              <a:rPr lang="en-US" sz="1000" dirty="0">
+                <a:solidFill>
+                  <a:srgbClr val="141412"/>
+                </a:solidFill>
+                <a:latin typeface="Calibri" pitchFamily="34" charset="0"/>
+                <a:ea typeface="Calibri" pitchFamily="34" charset="-122"/>
+                <a:cs typeface="Calibri" pitchFamily="34" charset="-120"/>
+              </a:rPr>
+              <a:t>Auditoría de cuenta, píxel y configuración técnica</a:t>
+            </a:r>
+            <a:endParaRPr lang="en-US" sz="1000" dirty="0"/>
+          </a:p>
+        </p:txBody>
+      </p:sp>
+      <p:sp>
+        <p:nvSpPr>
+          <p:cNvPr id="8" name="Shape 6"/>
+          <p:cNvSpPr/>
+          <p:nvPr/>
+        </p:nvSpPr>
+        <p:spPr>
+          <a:xfrm>
+            <a:off x="2322576" y="2377440"/>
+            <a:ext cx="1783080" cy="2286000"/>
+          </a:xfrm>
+          <a:prstGeom prst="roundRect">
+            <a:avLst>
+              <a:gd name="adj" fmla="val 4103"/>
+            </a:avLst>
+          </a:prstGeom>
+          <a:solidFill>
+            <a:srgbClr val="E9EFEA"/>
+          </a:solidFill>
+          <a:ln/>
+        </p:spPr>
+      </p:sp>
+      <p:sp>
+        <p:nvSpPr>
+          <p:cNvPr id="9" name="Text 7"/>
+          <p:cNvSpPr/>
+          <p:nvPr/>
+        </p:nvSpPr>
+        <p:spPr>
+          <a:xfrm>
+            <a:off x="2459736" y="2606040"/>
+            <a:ext cx="1508760" cy="365760"/>
+          </a:xfrm>
+          <a:prstGeom prst="rect">
+            <a:avLst/>
+          </a:prstGeom>
+          <a:noFill/>
+          <a:ln/>
+        </p:spPr>
+        <p:txBody>
+          <a:bodyPr wrap="square" lIns="0" tIns="0" rIns="0" bIns="0" rtlCol="0" anchor="ctr"/>
+          <a:lstStyle/>
+          <a:p>
+            <a:pPr algn="ctr" indent="0" marL="0">
+              <a:buNone/>
+            </a:pPr>
+            <a:r>
+              <a:rPr lang="en-US" sz="1300" b="1" dirty="0">
+                <a:solidFill>
+                  <a:srgbClr val="1F4A3C"/>
+                </a:solidFill>
+                <a:latin typeface="Cambria" pitchFamily="34" charset="0"/>
+                <a:ea typeface="Cambria" pitchFamily="34" charset="-122"/>
+                <a:cs typeface="Cambria" pitchFamily="34" charset="-120"/>
+              </a:rPr>
+              <a:t>Semana 3-4</a:t>
+            </a:r>
+            <a:endParaRPr lang="en-US" sz="1300" dirty="0"/>
+          </a:p>
+        </p:txBody>
+      </p:sp>
+      <p:sp>
+        <p:nvSpPr>
+          <p:cNvPr id="10" name="Text 8"/>
+          <p:cNvSpPr/>
+          <p:nvPr/>
+        </p:nvSpPr>
+        <p:spPr>
+          <a:xfrm>
+            <a:off x="2487168" y="3063240"/>
+            <a:ext cx="1453896" cy="1463040"/>
+          </a:xfrm>
+          <a:prstGeom prst="rect">
+            <a:avLst/>
+          </a:prstGeom>
+          <a:noFill/>
+          <a:ln/>
+        </p:spPr>
+        <p:txBody>
+          <a:bodyPr wrap="square" lIns="0" tIns="0" rIns="0" bIns="0" rtlCol="0" anchor="ctr"/>
+          <a:lstStyle/>
+          <a:p>
+            <a:pPr algn="ctr" indent="0" marL="0">
+              <a:buNone/>
+            </a:pPr>
+            <a:r>
+              <a:rPr lang="en-US" sz="1000" dirty="0">
+                <a:solidFill>
+                  <a:srgbClr val="141412"/>
+                </a:solidFill>
+                <a:latin typeface="Calibri" pitchFamily="34" charset="0"/>
+                <a:ea typeface="Calibri" pitchFamily="34" charset="-122"/>
+                <a:cs typeface="Calibri" pitchFamily="34" charset="-120"/>
+              </a:rPr>
+              <a:t>Lanzamiento de campañas de Presentación — aceite de romero</a:t>
+            </a:r>
+            <a:endParaRPr lang="en-US" sz="1000" dirty="0"/>
+          </a:p>
+        </p:txBody>
+      </p:sp>
+      <p:sp>
+        <p:nvSpPr>
+          <p:cNvPr id="11" name="Shape 9"/>
+          <p:cNvSpPr/>
+          <p:nvPr/>
+        </p:nvSpPr>
+        <p:spPr>
+          <a:xfrm>
+            <a:off x="4242816" y="2377440"/>
+            <a:ext cx="1783080" cy="2286000"/>
+          </a:xfrm>
+          <a:prstGeom prst="roundRect">
+            <a:avLst>
+              <a:gd name="adj" fmla="val 4103"/>
+            </a:avLst>
+          </a:prstGeom>
+          <a:solidFill>
+            <a:srgbClr val="F5F5F3"/>
+          </a:solidFill>
+          <a:ln/>
+        </p:spPr>
+      </p:sp>
+      <p:sp>
+        <p:nvSpPr>
+          <p:cNvPr id="12" name="Text 10"/>
+          <p:cNvSpPr/>
+          <p:nvPr/>
+        </p:nvSpPr>
+        <p:spPr>
+          <a:xfrm>
+            <a:off x="4379976" y="2606040"/>
+            <a:ext cx="1508760" cy="365760"/>
+          </a:xfrm>
+          <a:prstGeom prst="rect">
+            <a:avLst/>
+          </a:prstGeom>
+          <a:noFill/>
+          <a:ln/>
+        </p:spPr>
+        <p:txBody>
+          <a:bodyPr wrap="square" lIns="0" tIns="0" rIns="0" bIns="0" rtlCol="0" anchor="ctr"/>
+          <a:lstStyle/>
+          <a:p>
+            <a:pPr algn="ctr" indent="0" marL="0">
+              <a:buNone/>
+            </a:pPr>
+            <a:r>
+              <a:rPr lang="en-US" sz="1300" b="1" dirty="0">
+                <a:solidFill>
+                  <a:srgbClr val="1F4A3C"/>
+                </a:solidFill>
+                <a:latin typeface="Cambria" pitchFamily="34" charset="0"/>
+                <a:ea typeface="Cambria" pitchFamily="34" charset="-122"/>
+                <a:cs typeface="Cambria" pitchFamily="34" charset="-120"/>
+              </a:rPr>
+              <a:t>Semana 5-6</a:t>
+            </a:r>
+            <a:endParaRPr lang="en-US" sz="1300" dirty="0"/>
+          </a:p>
+        </p:txBody>
+      </p:sp>
+      <p:sp>
+        <p:nvSpPr>
+          <p:cNvPr id="13" name="Text 11"/>
+          <p:cNvSpPr/>
+          <p:nvPr/>
+        </p:nvSpPr>
+        <p:spPr>
+          <a:xfrm>
+            <a:off x="4407408" y="3063240"/>
+            <a:ext cx="1453896" cy="1463040"/>
+          </a:xfrm>
+          <a:prstGeom prst="rect">
+            <a:avLst/>
+          </a:prstGeom>
+          <a:noFill/>
+          <a:ln/>
+        </p:spPr>
+        <p:txBody>
+          <a:bodyPr wrap="square" lIns="0" tIns="0" rIns="0" bIns="0" rtlCol="0" anchor="ctr"/>
+          <a:lstStyle/>
+          <a:p>
+            <a:pPr algn="ctr" indent="0" marL="0">
+              <a:buNone/>
+            </a:pPr>
+            <a:r>
+              <a:rPr lang="en-US" sz="1000" dirty="0">
+                <a:solidFill>
+                  <a:srgbClr val="141412"/>
+                </a:solidFill>
+                <a:latin typeface="Calibri" pitchFamily="34" charset="0"/>
+                <a:ea typeface="Calibri" pitchFamily="34" charset="-122"/>
+                <a:cs typeface="Calibri" pitchFamily="34" charset="-120"/>
+              </a:rPr>
+              <a:t>Remarketing y prueba social — shampoo Vive</a:t>
+            </a:r>
+            <a:endParaRPr lang="en-US" sz="1000" dirty="0"/>
+          </a:p>
+        </p:txBody>
+      </p:sp>
+      <p:sp>
+        <p:nvSpPr>
+          <p:cNvPr id="14" name="Shape 12"/>
+          <p:cNvSpPr/>
+          <p:nvPr/>
+        </p:nvSpPr>
+        <p:spPr>
+          <a:xfrm>
+            <a:off x="6163056" y="2377440"/>
+            <a:ext cx="1783080" cy="2286000"/>
+          </a:xfrm>
+          <a:prstGeom prst="roundRect">
+            <a:avLst>
+              <a:gd name="adj" fmla="val 4103"/>
+            </a:avLst>
+          </a:prstGeom>
+          <a:solidFill>
+            <a:srgbClr val="E9EFEA"/>
+          </a:solidFill>
+          <a:ln/>
+        </p:spPr>
+      </p:sp>
+      <p:sp>
+        <p:nvSpPr>
+          <p:cNvPr id="15" name="Text 13"/>
+          <p:cNvSpPr/>
+          <p:nvPr/>
+        </p:nvSpPr>
+        <p:spPr>
+          <a:xfrm>
+            <a:off x="6300216" y="2606040"/>
+            <a:ext cx="1508760" cy="365760"/>
+          </a:xfrm>
+          <a:prstGeom prst="rect">
+            <a:avLst/>
+          </a:prstGeom>
+          <a:noFill/>
+          <a:ln/>
+        </p:spPr>
+        <p:txBody>
+          <a:bodyPr wrap="square" lIns="0" tIns="0" rIns="0" bIns="0" rtlCol="0" anchor="ctr"/>
+          <a:lstStyle/>
+          <a:p>
+            <a:pPr algn="ctr" indent="0" marL="0">
+              <a:buNone/>
+            </a:pPr>
+            <a:r>
+              <a:rPr lang="en-US" sz="1300" b="1" dirty="0">
+                <a:solidFill>
+                  <a:srgbClr val="1F4A3C"/>
+                </a:solidFill>
+                <a:latin typeface="Cambria" pitchFamily="34" charset="0"/>
+                <a:ea typeface="Cambria" pitchFamily="34" charset="-122"/>
+                <a:cs typeface="Cambria" pitchFamily="34" charset="-120"/>
+              </a:rPr>
+              <a:t>Semana 7-8</a:t>
+            </a:r>
+            <a:endParaRPr lang="en-US" sz="1300" dirty="0"/>
+          </a:p>
+        </p:txBody>
+      </p:sp>
+      <p:sp>
+        <p:nvSpPr>
+          <p:cNvPr id="16" name="Text 14"/>
+          <p:cNvSpPr/>
+          <p:nvPr/>
+        </p:nvSpPr>
+        <p:spPr>
+          <a:xfrm>
+            <a:off x="6327648" y="3063240"/>
+            <a:ext cx="1453896" cy="1463040"/>
+          </a:xfrm>
+          <a:prstGeom prst="rect">
+            <a:avLst/>
+          </a:prstGeom>
+          <a:noFill/>
+          <a:ln/>
+        </p:spPr>
+        <p:txBody>
+          <a:bodyPr wrap="square" lIns="0" tIns="0" rIns="0" bIns="0" rtlCol="0" anchor="ctr"/>
+          <a:lstStyle/>
+          <a:p>
+            <a:pPr algn="ctr" indent="0" marL="0">
+              <a:buNone/>
+            </a:pPr>
+            <a:r>
+              <a:rPr lang="en-US" sz="1000" dirty="0">
+                <a:solidFill>
+                  <a:srgbClr val="141412"/>
+                </a:solidFill>
+                <a:latin typeface="Calibri" pitchFamily="34" charset="0"/>
+                <a:ea typeface="Calibri" pitchFamily="34" charset="-122"/>
+                <a:cs typeface="Calibri" pitchFamily="34" charset="-120"/>
+              </a:rPr>
+              <a:t>Primeras campañas de Conversión con oferta de lanzamiento</a:t>
+            </a:r>
+            <a:endParaRPr lang="en-US" sz="1000" dirty="0"/>
+          </a:p>
+        </p:txBody>
+      </p:sp>
+      <p:sp>
+        <p:nvSpPr>
+          <p:cNvPr id="17" name="Shape 15"/>
+          <p:cNvSpPr/>
+          <p:nvPr/>
+        </p:nvSpPr>
+        <p:spPr>
+          <a:xfrm>
+            <a:off x="8083296" y="2377440"/>
+            <a:ext cx="1783080" cy="2286000"/>
+          </a:xfrm>
+          <a:prstGeom prst="roundRect">
+            <a:avLst>
+              <a:gd name="adj" fmla="val 4103"/>
+            </a:avLst>
+          </a:prstGeom>
+          <a:solidFill>
+            <a:srgbClr val="F5F5F3"/>
+          </a:solidFill>
+          <a:ln/>
+        </p:spPr>
+      </p:sp>
+      <p:sp>
+        <p:nvSpPr>
+          <p:cNvPr id="18" name="Text 16"/>
+          <p:cNvSpPr/>
+          <p:nvPr/>
+        </p:nvSpPr>
+        <p:spPr>
+          <a:xfrm>
+            <a:off x="8220456" y="2606040"/>
+            <a:ext cx="1508760" cy="365760"/>
+          </a:xfrm>
+          <a:prstGeom prst="rect">
+            <a:avLst/>
+          </a:prstGeom>
+          <a:noFill/>
+          <a:ln/>
+        </p:spPr>
+        <p:txBody>
+          <a:bodyPr wrap="square" lIns="0" tIns="0" rIns="0" bIns="0" rtlCol="0" anchor="ctr"/>
+          <a:lstStyle/>
+          <a:p>
+            <a:pPr algn="ctr" indent="0" marL="0">
+              <a:buNone/>
+            </a:pPr>
+            <a:r>
+              <a:rPr lang="en-US" sz="1300" b="1" dirty="0">
+                <a:solidFill>
+                  <a:srgbClr val="1F4A3C"/>
+                </a:solidFill>
+                <a:latin typeface="Cambria" pitchFamily="34" charset="0"/>
+                <a:ea typeface="Cambria" pitchFamily="34" charset="-122"/>
+                <a:cs typeface="Cambria" pitchFamily="34" charset="-120"/>
+              </a:rPr>
+              <a:t>Semana 9-10</a:t>
+            </a:r>
+            <a:endParaRPr lang="en-US" sz="1300" dirty="0"/>
+          </a:p>
+        </p:txBody>
+      </p:sp>
+      <p:sp>
+        <p:nvSpPr>
+          <p:cNvPr id="19" name="Text 17"/>
+          <p:cNvSpPr/>
+          <p:nvPr/>
+        </p:nvSpPr>
+        <p:spPr>
+          <a:xfrm>
+            <a:off x="8247888" y="3063240"/>
+            <a:ext cx="1453896" cy="1463040"/>
+          </a:xfrm>
+          <a:prstGeom prst="rect">
+            <a:avLst/>
+          </a:prstGeom>
+          <a:noFill/>
+          <a:ln/>
+        </p:spPr>
+        <p:txBody>
+          <a:bodyPr wrap="square" lIns="0" tIns="0" rIns="0" bIns="0" rtlCol="0" anchor="ctr"/>
+          <a:lstStyle/>
+          <a:p>
+            <a:pPr algn="ctr" indent="0" marL="0">
+              <a:buNone/>
+            </a:pPr>
+            <a:r>
+              <a:rPr lang="en-US" sz="1000" dirty="0">
+                <a:solidFill>
+                  <a:srgbClr val="141412"/>
+                </a:solidFill>
+                <a:latin typeface="Calibri" pitchFamily="34" charset="0"/>
+                <a:ea typeface="Calibri" pitchFamily="34" charset="-122"/>
+                <a:cs typeface="Calibri" pitchFamily="34" charset="-120"/>
+              </a:rPr>
+              <a:t>Optimización de campañas ganadoras — rutina completa</a:t>
+            </a:r>
+            <a:endParaRPr lang="en-US" sz="1000" dirty="0"/>
+          </a:p>
+        </p:txBody>
+      </p:sp>
+      <p:sp>
+        <p:nvSpPr>
+          <p:cNvPr id="20" name="Shape 18"/>
+          <p:cNvSpPr/>
+          <p:nvPr/>
+        </p:nvSpPr>
+        <p:spPr>
+          <a:xfrm>
+            <a:off x="10003536" y="2377440"/>
+            <a:ext cx="1783080" cy="2286000"/>
+          </a:xfrm>
+          <a:prstGeom prst="roundRect">
+            <a:avLst>
+              <a:gd name="adj" fmla="val 4103"/>
+            </a:avLst>
+          </a:prstGeom>
+          <a:solidFill>
+            <a:srgbClr val="1F4A3C"/>
+          </a:solidFill>
+          <a:ln/>
+        </p:spPr>
+      </p:sp>
+      <p:sp>
+        <p:nvSpPr>
+          <p:cNvPr id="21" name="Text 19"/>
+          <p:cNvSpPr/>
+          <p:nvPr/>
+        </p:nvSpPr>
+        <p:spPr>
+          <a:xfrm>
+            <a:off x="10140696" y="2606040"/>
+            <a:ext cx="1508760" cy="365760"/>
+          </a:xfrm>
+          <a:prstGeom prst="rect">
+            <a:avLst/>
+          </a:prstGeom>
+          <a:noFill/>
+          <a:ln/>
+        </p:spPr>
+        <p:txBody>
+          <a:bodyPr wrap="square" lIns="0" tIns="0" rIns="0" bIns="0" rtlCol="0" anchor="ctr"/>
+          <a:lstStyle/>
+          <a:p>
+            <a:pPr algn="ctr" indent="0" marL="0">
+              <a:buNone/>
+            </a:pPr>
+            <a:r>
+              <a:rPr lang="en-US" sz="1300" b="1" dirty="0">
+                <a:solidFill>
+                  <a:srgbClr val="FFFFFF"/>
+                </a:solidFill>
+                <a:latin typeface="Cambria" pitchFamily="34" charset="0"/>
+                <a:ea typeface="Cambria" pitchFamily="34" charset="-122"/>
+                <a:cs typeface="Cambria" pitchFamily="34" charset="-120"/>
+              </a:rPr>
+              <a:t>Semana 11-12</a:t>
+            </a:r>
+            <a:endParaRPr lang="en-US" sz="1300" dirty="0"/>
+          </a:p>
+        </p:txBody>
+      </p:sp>
+      <p:sp>
+        <p:nvSpPr>
+          <p:cNvPr id="22" name="Text 20"/>
+          <p:cNvSpPr/>
+          <p:nvPr/>
+        </p:nvSpPr>
+        <p:spPr>
+          <a:xfrm>
+            <a:off x="10168128" y="3063240"/>
+            <a:ext cx="1453896" cy="1463040"/>
+          </a:xfrm>
+          <a:prstGeom prst="rect">
+            <a:avLst/>
+          </a:prstGeom>
+          <a:noFill/>
+          <a:ln/>
+        </p:spPr>
+        <p:txBody>
+          <a:bodyPr wrap="square" lIns="0" tIns="0" rIns="0" bIns="0" rtlCol="0" anchor="ctr"/>
+          <a:lstStyle/>
+          <a:p>
+            <a:pPr algn="ctr" indent="0" marL="0">
+              <a:buNone/>
+            </a:pPr>
+            <a:r>
+              <a:rPr lang="en-US" sz="1000" dirty="0">
+                <a:solidFill>
+                  <a:srgbClr val="EAF0EC"/>
+                </a:solidFill>
+                <a:latin typeface="Calibri" pitchFamily="34" charset="0"/>
+                <a:ea typeface="Calibri" pitchFamily="34" charset="-122"/>
+                <a:cs typeface="Calibri" pitchFamily="34" charset="-120"/>
+              </a:rPr>
+              <a:t>Arranque de Ascensión: primer público de recompra</a:t>
+            </a:r>
+            <a:endParaRPr lang="en-US" sz="1000" dirty="0"/>
+          </a:p>
+        </p:txBody>
+      </p:sp>
+      <p:sp>
+        <p:nvSpPr>
+          <p:cNvPr id="23" name="Text 21"/>
+          <p:cNvSpPr/>
+          <p:nvPr/>
+        </p:nvSpPr>
+        <p:spPr>
+          <a:xfrm>
+            <a:off x="640080" y="5029200"/>
+            <a:ext cx="10881360" cy="548640"/>
+          </a:xfrm>
+          <a:prstGeom prst="rect">
+            <a:avLst/>
+          </a:prstGeom>
+          <a:noFill/>
+          <a:ln/>
+        </p:spPr>
+        <p:txBody>
+          <a:bodyPr wrap="square" lIns="0" tIns="0" rIns="0" bIns="0" rtlCol="0" anchor="ctr"/>
+          <a:lstStyle/>
+          <a:p>
+            <a:pPr indent="0" marL="0">
+              <a:buNone/>
+            </a:pPr>
+            <a:r>
+              <a:rPr lang="en-US" sz="1300" i="1" dirty="0">
+                <a:solidFill>
+                  <a:srgbClr val="141412"/>
+                </a:solidFill>
+                <a:latin typeface="Calibri" pitchFamily="34" charset="0"/>
+                <a:ea typeface="Calibri" pitchFamily="34" charset="-122"/>
+                <a:cs typeface="Calibri" pitchFamily="34" charset="-120"/>
+              </a:rPr>
+              <a:t>Al cierre del mes 3, el sistema completo está activo: descubrimiento, confianza, conversión y las primeras señales de recompra.</a:t>
+            </a:r>
+            <a:endParaRPr lang="en-US" sz="1300" dirty="0"/>
+          </a:p>
+        </p:txBody>
+      </p:sp>
+      <p:sp>
+        <p:nvSpPr>
+          <p:cNvPr id="24" name="Text 22"/>
+          <p:cNvSpPr/>
+          <p:nvPr/>
+        </p:nvSpPr>
+        <p:spPr>
+          <a:xfrm>
+            <a:off x="11365992" y="6400800"/>
+            <a:ext cx="548640" cy="274320"/>
+          </a:xfrm>
+          <a:prstGeom prst="rect">
+            <a:avLst/>
+          </a:prstGeom>
+          <a:noFill/>
+          <a:ln/>
+        </p:spPr>
+        <p:txBody>
+          <a:bodyPr wrap="square" lIns="0" tIns="0" rIns="0" bIns="0" rtlCol="0" anchor="ctr"/>
+          <a:lstStyle/>
+          <a:p>
+            <a:pPr algn="r" indent="0" marL="0">
+              <a:buNone/>
+            </a:pPr>
+            <a:r>
+              <a:rPr lang="en-US" sz="1000" dirty="0">
+                <a:solidFill>
+                  <a:srgbClr val="6B6B66"/>
+                </a:solidFill>
+                <a:latin typeface="Calibri" pitchFamily="34" charset="0"/>
+                <a:ea typeface="Calibri" pitchFamily="34" charset="-122"/>
+                <a:cs typeface="Calibri" pitchFamily="34" charset="-120"/>
+              </a:rPr>
+              <a:t>17</a:t>
+            </a:r>
+            <a:endParaRPr lang="en-US" sz="1000" dirty="0"/>
+          </a:p>
+        </p:txBody>
+      </p:sp>
+    </p:spTree>
+  </p:cSld>
+  <p:clrMapOvr>
+    <a:masterClrMapping/>
+  </p:clrMapOvr>
+</p:sld>
+</file>
+
+<file path=ppt/slides/slide18.xml><?xml version="1.0" encoding="utf-8"?>
+<p:sld xmlns:a="http://schemas.openxmlformats.org/drawingml/2006/main" xmlns:r="http://schemas.openxmlformats.org/officeDocument/2006/relationships" xmlns:p="http://schemas.openxmlformats.org/presentationml/2006/main">
+  <p:cSld name="Slide 18">
     <p:bg>
       <p:bgPr>
         <a:solidFill>
@@ -7899,7 +10261,7 @@
                 <a:ea typeface="Calibri" pitchFamily="34" charset="-122"/>
                 <a:cs typeface="Calibri" pitchFamily="34" charset="-120"/>
               </a:rPr>
-              <a:t>16</a:t>
+              <a:t>18</a:t>
             </a:r>
             <a:endParaRPr lang="en-US" sz="1000" dirty="0"/>
           </a:p>

</xml_diff>